<commit_message>
add the print lables for certs
</commit_message>
<xml_diff>
--- a/doc/BIP_with_Andrew_Pincherle_DEV2.pptx
+++ b/doc/BIP_with_Andrew_Pincherle_DEV2.pptx
@@ -373,7 +373,7 @@
           <a:p>
             <a:fld id="{1D8BD707-D9CF-40AE-B4C6-C98DA3205C09}" type="datetimeFigureOut">
               <a:rPr lang="en-US"/>
-              <a:t>11/7/2025</a:t>
+              <a:t>6/15/2026</a:t>
             </a:fld>
             <a:endParaRPr lang="en-US"/>
           </a:p>
@@ -558,7 +558,7 @@
           <a:p>
             <a:fld id="{1D8BD707-D9CF-40AE-B4C6-C98DA3205C09}" type="datetimeFigureOut">
               <a:rPr lang="en-US"/>
-              <a:t>11/7/2025</a:t>
+              <a:t>6/15/2026</a:t>
             </a:fld>
             <a:endParaRPr lang="en-US"/>
           </a:p>
@@ -786,7 +786,7 @@
           <a:p>
             <a:fld id="{1D8BD707-D9CF-40AE-B4C6-C98DA3205C09}" type="datetimeFigureOut">
               <a:rPr lang="en-US"/>
-              <a:t>11/7/2025</a:t>
+              <a:t>6/15/2026</a:t>
             </a:fld>
             <a:endParaRPr lang="en-US"/>
           </a:p>
@@ -948,7 +948,7 @@
           <a:p>
             <a:fld id="{1D8BD707-D9CF-40AE-B4C6-C98DA3205C09}" type="datetimeFigureOut">
               <a:rPr lang="en-US"/>
-              <a:t>11/7/2025</a:t>
+              <a:t>6/15/2026</a:t>
             </a:fld>
             <a:endParaRPr lang="en-US"/>
           </a:p>
@@ -1081,7 +1081,7 @@
           <a:p>
             <a:fld id="{1D8BD707-D9CF-40AE-B4C6-C98DA3205C09}" type="datetimeFigureOut">
               <a:rPr lang="en-US"/>
-              <a:t>11/7/2025</a:t>
+              <a:t>6/15/2026</a:t>
             </a:fld>
             <a:endParaRPr lang="en-US"/>
           </a:p>
@@ -1336,7 +1336,7 @@
           <a:p>
             <a:fld id="{1D8BD707-D9CF-40AE-B4C6-C98DA3205C09}" type="datetimeFigureOut">
               <a:rPr lang="en-US"/>
-              <a:t>11/7/2025</a:t>
+              <a:t>6/15/2026</a:t>
             </a:fld>
             <a:endParaRPr lang="en-US"/>
           </a:p>
@@ -1820,7 +1820,7 @@
               <a:t> </a:t>
             </a:r>
             <a:r>
-              <a:rPr kumimoji="0" sz="1200" b="0" i="0" u="none" strike="noStrike" kern="0" cap="none" spc="80" normalizeH="0" baseline="0" noProof="0" dirty="0">
+              <a:rPr kumimoji="0" lang="en-GB" sz="1200" b="0" i="0" u="none" strike="noStrike" kern="0" cap="none" spc="80" normalizeH="0" baseline="0" noProof="0" dirty="0">
                 <a:ln>
                   <a:noFill/>
                 </a:ln>
@@ -1835,7 +1835,7 @@
               </a:rPr>
               <a:t>2025</a:t>
             </a:r>
-            <a:endParaRPr kumimoji="0" sz="1200" b="0" i="0" u="none" strike="noStrike" kern="0" cap="none" spc="0" normalizeH="0" baseline="0" noProof="0">
+            <a:endParaRPr kumimoji="0" sz="1200" b="0" i="0" u="none" strike="noStrike" kern="0" cap="none" spc="0" normalizeH="0" baseline="0" noProof="0" dirty="0">
               <a:ln>
                 <a:noFill/>
               </a:ln>
@@ -1890,7 +1890,7 @@
               <a:defRPr/>
             </a:pPr>
             <a:r>
-              <a:rPr kumimoji="0" sz="1600" b="1" i="0" u="none" strike="noStrike" kern="0" cap="none" spc="45" normalizeH="0" baseline="0" noProof="0" dirty="0">
+              <a:rPr kumimoji="0" lang="en-GB" sz="1600" b="1" i="0" u="none" strike="noStrike" kern="0" cap="none" spc="45" normalizeH="0" baseline="0" noProof="0">
                 <a:ln>
                   <a:noFill/>
                 </a:ln>
@@ -1906,7 +1906,7 @@
               <a:t>Profiles</a:t>
             </a:r>
             <a:r>
-              <a:rPr kumimoji="0" sz="1600" b="1" i="0" u="none" strike="noStrike" kern="0" cap="none" spc="175" normalizeH="0" baseline="0" noProof="0" dirty="0">
+              <a:rPr kumimoji="0" lang="en-GB" sz="1600" b="1" i="0" u="none" strike="noStrike" kern="0" cap="none" spc="175" normalizeH="0" baseline="0" noProof="0">
                 <a:ln>
                   <a:noFill/>
                 </a:ln>
@@ -1922,7 +1922,7 @@
               <a:t> </a:t>
             </a:r>
             <a:r>
-              <a:rPr kumimoji="0" sz="1600" b="1" i="0" u="none" strike="noStrike" kern="0" cap="none" spc="0" normalizeH="0" baseline="0" noProof="0" dirty="0">
+              <a:rPr kumimoji="0" lang="en-GB" sz="1600" b="1" i="0" u="none" strike="noStrike" kern="0" cap="none" spc="0" normalizeH="0" baseline="0" noProof="0">
                 <a:ln>
                   <a:noFill/>
                 </a:ln>
@@ -1938,7 +1938,7 @@
               <a:t>for</a:t>
             </a:r>
             <a:r>
-              <a:rPr kumimoji="0" sz="1600" b="1" i="0" u="none" strike="noStrike" kern="0" cap="none" spc="155" normalizeH="0" baseline="0" noProof="0" dirty="0">
+              <a:rPr kumimoji="0" lang="en-GB" sz="1600" b="1" i="0" u="none" strike="noStrike" kern="0" cap="none" spc="155" normalizeH="0" baseline="0" noProof="0">
                 <a:ln>
                   <a:noFill/>
                 </a:ln>
@@ -1954,7 +1954,7 @@
               <a:t> </a:t>
             </a:r>
             <a:r>
-              <a:rPr kumimoji="0" sz="1600" b="1" i="0" u="none" strike="noStrike" kern="0" cap="none" spc="0" normalizeH="0" baseline="0" noProof="0" dirty="0">
+              <a:rPr kumimoji="0" lang="en-GB" sz="1600" b="1" i="0" u="none" strike="noStrike" kern="0" cap="none" spc="0" normalizeH="0" baseline="0" noProof="0">
                 <a:ln>
                   <a:noFill/>
                 </a:ln>
@@ -1970,7 +1970,7 @@
               <a:t>consideration</a:t>
             </a:r>
             <a:r>
-              <a:rPr kumimoji="0" sz="1600" b="1" i="0" u="none" strike="noStrike" kern="0" cap="none" spc="175" normalizeH="0" baseline="0" noProof="0" dirty="0">
+              <a:rPr kumimoji="0" lang="en-GB" sz="1600" b="1" i="0" u="none" strike="noStrike" kern="0" cap="none" spc="175" normalizeH="0" baseline="0" noProof="0">
                 <a:ln>
                   <a:noFill/>
                 </a:ln>
@@ -1986,7 +1986,7 @@
               <a:t> </a:t>
             </a:r>
             <a:r>
-              <a:rPr kumimoji="0" sz="1600" b="1" i="0" u="none" strike="noStrike" kern="0" cap="none" spc="280" normalizeH="0" baseline="0" noProof="0" dirty="0">
+              <a:rPr kumimoji="0" lang="en-GB" sz="1600" b="1" i="0" u="none" strike="noStrike" kern="0" cap="none" spc="280" normalizeH="0" baseline="0" noProof="0">
                 <a:ln>
                   <a:noFill/>
                 </a:ln>
@@ -2002,7 +2002,7 @@
               <a:t>–</a:t>
             </a:r>
             <a:r>
-              <a:rPr kumimoji="0" sz="1600" b="1" i="0" u="none" strike="noStrike" kern="0" cap="none" spc="150" normalizeH="0" baseline="0" noProof="0" dirty="0">
+              <a:rPr kumimoji="0" lang="en-GB" sz="1600" b="1" i="0" u="none" strike="noStrike" kern="0" cap="none" spc="150" normalizeH="0" baseline="0" noProof="0">
                 <a:ln>
                   <a:noFill/>
                 </a:ln>
@@ -2018,7 +2018,7 @@
               <a:t> </a:t>
             </a:r>
             <a:r>
-              <a:rPr kumimoji="0" sz="1600" b="1" i="0" u="none" strike="noStrike" kern="0" cap="none" spc="170" normalizeH="0" baseline="0" noProof="0" dirty="0">
+              <a:rPr kumimoji="0" lang="en-GB" sz="1600" b="1" i="0" u="none" strike="noStrike" kern="0" cap="none" spc="170" normalizeH="0" baseline="0" noProof="0">
                 <a:ln>
                   <a:noFill/>
                 </a:ln>
@@ -2034,7 +2034,7 @@
               <a:t> </a:t>
             </a:r>
             <a:r>
-              <a:rPr lang="en-GB" sz="1600" b="1" kern="0" spc="-20" dirty="0">
+              <a:rPr lang="en-GB" sz="1600" b="1" kern="0" spc="-20">
                 <a:solidFill>
                   <a:srgbClr val="FFFFFF"/>
                 </a:solidFill>
@@ -2043,7 +2043,7 @@
               </a:rPr>
               <a:t>Developer</a:t>
             </a:r>
-            <a:endParaRPr kumimoji="0" sz="1600" b="0" i="0" u="none" strike="noStrike" kern="0" cap="none" spc="0" normalizeH="0" baseline="0" noProof="0" dirty="0">
+            <a:endParaRPr kumimoji="0" lang="en-GB" sz="1600" b="0" i="0" u="none" strike="noStrike" kern="0" cap="none" spc="0" normalizeH="0" baseline="0" noProof="0" dirty="0">
               <a:ln>
                 <a:noFill/>
               </a:ln>
@@ -7861,15 +7861,6 @@
 </file>
 
 <file path=customXml/item2.xml><?xml version="1.0" encoding="utf-8"?>
-<?mso-contentType ?>
-<FormTemplates xmlns="http://schemas.microsoft.com/sharepoint/v3/contenttype/forms">
-  <Display>DocumentLibraryForm</Display>
-  <Edit>DocumentLibraryForm</Edit>
-  <New>DocumentLibraryForm</New>
-</FormTemplates>
-</file>
-
-<file path=customXml/item3.xml><?xml version="1.0" encoding="utf-8"?>
 <p:properties xmlns:p="http://schemas.microsoft.com/office/2006/metadata/properties" xmlns:xsi="http://www.w3.org/2001/XMLSchema-instance" xmlns:pc="http://schemas.microsoft.com/office/infopath/2007/PartnerControls">
   <documentManagement>
     <Document_x0020_Access_x0020_Level xmlns="e623b38d-c367-4d58-8eb6-b4ce6998f19b">Restricted</Document_x0020_Access_x0020_Level>
@@ -7879,6 +7870,15 @@
     <TaxCatchAll xmlns="c7638ba2-7af8-4996-b3aa-a9907f187b8b" xsi:nil="true"/>
   </documentManagement>
 </p:properties>
+</file>
+
+<file path=customXml/item3.xml><?xml version="1.0" encoding="utf-8"?>
+<?mso-contentType ?>
+<FormTemplates xmlns="http://schemas.microsoft.com/sharepoint/v3/contenttype/forms">
+  <Display>DocumentLibraryForm</Display>
+  <Edit>DocumentLibraryForm</Edit>
+  <New>DocumentLibraryForm</New>
+</FormTemplates>
 </file>
 
 <file path=customXml/itemProps1.xml><?xml version="1.0" encoding="utf-8"?>
@@ -7901,14 +7901,6 @@
 </file>
 
 <file path=customXml/itemProps2.xml><?xml version="1.0" encoding="utf-8"?>
-<ds:datastoreItem xmlns:ds="http://schemas.openxmlformats.org/officeDocument/2006/customXml" ds:itemID="{996A8CEB-3438-4987-B662-3C9F19589771}">
-  <ds:schemaRefs>
-    <ds:schemaRef ds:uri="http://schemas.microsoft.com/sharepoint/v3/contenttype/forms"/>
-  </ds:schemaRefs>
-</ds:datastoreItem>
-</file>
-
-<file path=customXml/itemProps3.xml><?xml version="1.0" encoding="utf-8"?>
 <ds:datastoreItem xmlns:ds="http://schemas.openxmlformats.org/officeDocument/2006/customXml" ds:itemID="{3D1F0D08-78DB-4998-BB4F-A4B7B1422C5A}">
   <ds:schemaRefs>
     <ds:schemaRef ds:uri="http://schemas.microsoft.com/office/2006/metadata/properties"/>
@@ -7919,6 +7911,14 @@
 </ds:datastoreItem>
 </file>
 
+<file path=customXml/itemProps3.xml><?xml version="1.0" encoding="utf-8"?>
+<ds:datastoreItem xmlns:ds="http://schemas.openxmlformats.org/officeDocument/2006/customXml" ds:itemID="{996A8CEB-3438-4987-B662-3C9F19589771}">
+  <ds:schemaRefs>
+    <ds:schemaRef ds:uri="http://schemas.microsoft.com/sharepoint/v3/contenttype/forms"/>
+  </ds:schemaRefs>
+</ds:datastoreItem>
+</file>
+
 <file path=docMetadata/LabelInfo.xml><?xml version="1.0" encoding="utf-8"?>
 <clbl:labelList xmlns:clbl="http://schemas.microsoft.com/office/2020/mipLabelMetadata">
   <clbl:label id="{68806974-032c-4a81-90c9-0d775a0a9db8}" enabled="0" method="" siteId="{68806974-032c-4a81-90c9-0d775a0a9db8}" removed="1"/>

</xml_diff>